<commit_message>
Add per-year unit and revenue labels to compact sales graph
Unit counts labeled above each bar; revenue values shown in a row
beneath each year, aligned with the trend line. Kept as native editable
shapes (67 shapes, 0 pictures after .ppt conversion).

Co-Authored-By: Claude Fable 5 <noreply@anthropic.com>
Claude-Session: https://claude.ai/code/session_01NdEEtntN6L9HVXghGAQF2Z
</commit_message>
<xml_diff>
--- a/Sales_Graph_Compact.pptx
+++ b/Sales_Graph_Compact.pptx
@@ -502,7 +502,7 @@
           <a:p>
             <a:r>
               <a:rPr lang="en-US" dirty="0"/>
-              <a:t>Compact Units + Revenue graph sized (~3.9 x 2.0 in) to drop into the 'Sales Volumes (Units) and Revenue' area of the CHOICE Development Program slide. Native editable shapes: navy columns = units (left axis), gold line = revenue $M (right axis). No title/KPI cards since the host slide already provides them. Positioned at the slot location so copy-paste lands in place.</a:t>
+              <a:t>Compact Units + Revenue graph. Unit counts labeled above each navy bar; revenue $M values shown in a row beneath each year (aligned with the gold trend line). Native editable shapes, sized for the Sales Volumes area of the CHOICE slide.</a:t>
             </a:r>
             <a:endParaRPr lang="en-US" dirty="0"/>
           </a:p>
@@ -883,8 +883,8 @@
         </p:nvSpPr>
         <p:spPr>
           <a:xfrm>
-            <a:off x="960120" y="4892040"/>
-            <a:ext cx="2651760" cy="0"/>
+            <a:off x="960120" y="4773168"/>
+            <a:ext cx="2880360" cy="0"/>
           </a:xfrm>
           <a:prstGeom prst="line">
             <a:avLst/>
@@ -906,7 +906,7 @@
         </p:nvSpPr>
         <p:spPr>
           <a:xfrm>
-            <a:off x="301752" y="4800600"/>
+            <a:off x="301752" y="4681728"/>
             <a:ext cx="566928" cy="182880"/>
           </a:xfrm>
           <a:prstGeom prst="rect">
@@ -945,7 +945,7 @@
         </p:nvSpPr>
         <p:spPr>
           <a:xfrm>
-            <a:off x="3666744" y="4800600"/>
+            <a:off x="3895344" y="4681728"/>
             <a:ext cx="365760" cy="182880"/>
           </a:xfrm>
           <a:prstGeom prst="rect">
@@ -984,8 +984,8 @@
         </p:nvSpPr>
         <p:spPr>
           <a:xfrm>
-            <a:off x="960120" y="4465320"/>
-            <a:ext cx="2651760" cy="0"/>
+            <a:off x="960120" y="4423083"/>
+            <a:ext cx="2880360" cy="0"/>
           </a:xfrm>
           <a:prstGeom prst="line">
             <a:avLst/>
@@ -1007,7 +1007,7 @@
         </p:nvSpPr>
         <p:spPr>
           <a:xfrm>
-            <a:off x="301752" y="4373880"/>
+            <a:off x="301752" y="4331643"/>
             <a:ext cx="566928" cy="182880"/>
           </a:xfrm>
           <a:prstGeom prst="rect">
@@ -1046,7 +1046,7 @@
         </p:nvSpPr>
         <p:spPr>
           <a:xfrm>
-            <a:off x="3666744" y="4373880"/>
+            <a:off x="3895344" y="4331643"/>
             <a:ext cx="365760" cy="182880"/>
           </a:xfrm>
           <a:prstGeom prst="rect">
@@ -1085,8 +1085,8 @@
         </p:nvSpPr>
         <p:spPr>
           <a:xfrm>
-            <a:off x="960120" y="4038600"/>
-            <a:ext cx="2651760" cy="0"/>
+            <a:off x="960120" y="4072999"/>
+            <a:ext cx="2880360" cy="0"/>
           </a:xfrm>
           <a:prstGeom prst="line">
             <a:avLst/>
@@ -1108,7 +1108,7 @@
         </p:nvSpPr>
         <p:spPr>
           <a:xfrm>
-            <a:off x="301752" y="3947160"/>
+            <a:off x="301752" y="3981559"/>
             <a:ext cx="566928" cy="182880"/>
           </a:xfrm>
           <a:prstGeom prst="rect">
@@ -1147,7 +1147,7 @@
         </p:nvSpPr>
         <p:spPr>
           <a:xfrm>
-            <a:off x="3666744" y="3947160"/>
+            <a:off x="3895344" y="3981559"/>
             <a:ext cx="365760" cy="182880"/>
           </a:xfrm>
           <a:prstGeom prst="rect">
@@ -1186,8 +1186,8 @@
         </p:nvSpPr>
         <p:spPr>
           <a:xfrm>
-            <a:off x="960120" y="3611880"/>
-            <a:ext cx="2651760" cy="0"/>
+            <a:off x="960120" y="3722914"/>
+            <a:ext cx="2880360" cy="0"/>
           </a:xfrm>
           <a:prstGeom prst="line">
             <a:avLst/>
@@ -1209,7 +1209,7 @@
         </p:nvSpPr>
         <p:spPr>
           <a:xfrm>
-            <a:off x="301752" y="3520440"/>
+            <a:off x="301752" y="3631474"/>
             <a:ext cx="566928" cy="182880"/>
           </a:xfrm>
           <a:prstGeom prst="rect">
@@ -1248,7 +1248,7 @@
         </p:nvSpPr>
         <p:spPr>
           <a:xfrm>
-            <a:off x="3666744" y="3520440"/>
+            <a:off x="3895344" y="3631474"/>
             <a:ext cx="365760" cy="182880"/>
           </a:xfrm>
           <a:prstGeom prst="rect">
@@ -1287,7 +1287,7 @@
         </p:nvSpPr>
         <p:spPr>
           <a:xfrm>
-            <a:off x="301752" y="3392424"/>
+            <a:off x="301752" y="3529584"/>
             <a:ext cx="566928" cy="164592"/>
           </a:xfrm>
           <a:prstGeom prst="rect">
@@ -1326,7 +1326,7 @@
         </p:nvSpPr>
         <p:spPr>
           <a:xfrm>
-            <a:off x="3666744" y="3392424"/>
+            <a:off x="3895344" y="3529584"/>
             <a:ext cx="365760" cy="164592"/>
           </a:xfrm>
           <a:prstGeom prst="rect">
@@ -1359,53 +1359,73 @@
       </p:sp>
       <p:sp>
         <p:nvSpPr>
-          <p:cNvPr id="16" name="Text 14"/>
-          <p:cNvSpPr/>
-          <p:nvPr/>
-        </p:nvSpPr>
-        <p:spPr>
-          <a:xfrm>
-            <a:off x="960120" y="4928616"/>
-            <a:ext cx="331470" cy="182880"/>
-          </a:xfrm>
-          <a:prstGeom prst="rect">
-            <a:avLst/>
-          </a:prstGeom>
-          <a:noFill/>
-          <a:ln/>
-        </p:spPr>
-        <p:txBody>
-          <a:bodyPr wrap="square" lIns="0" tIns="0" rIns="0" bIns="0" rtlCol="0" anchor="t"/>
+          <p:cNvPr id="16" name="Shape 14"/>
+          <p:cNvSpPr/>
+          <p:nvPr/>
+        </p:nvSpPr>
+        <p:spPr>
+          <a:xfrm>
+            <a:off x="1053275" y="4768734"/>
+            <a:ext cx="173736" cy="4434"/>
+          </a:xfrm>
+          <a:prstGeom prst="rect">
+            <a:avLst/>
+          </a:prstGeom>
+          <a:solidFill>
+            <a:srgbClr val="1E2761"/>
+          </a:solidFill>
+          <a:ln/>
+        </p:spPr>
+      </p:sp>
+      <p:sp>
+        <p:nvSpPr>
+          <p:cNvPr id="17" name="Text 15"/>
+          <p:cNvSpPr/>
+          <p:nvPr/>
+        </p:nvSpPr>
+        <p:spPr>
+          <a:xfrm>
+            <a:off x="756095" y="4553712"/>
+            <a:ext cx="768096" cy="137160"/>
+          </a:xfrm>
+          <a:prstGeom prst="rect">
+            <a:avLst/>
+          </a:prstGeom>
+          <a:noFill/>
+          <a:ln/>
+        </p:spPr>
+        <p:txBody>
+          <a:bodyPr wrap="square" lIns="0" tIns="0" rIns="0" bIns="0" rtlCol="0" anchor="b"/>
           <a:lstStyle/>
           <a:p>
             <a:pPr algn="ctr" indent="0" marL="0">
               <a:buNone/>
             </a:pPr>
             <a:r>
-              <a:rPr lang="en-US" sz="700" dirty="0">
-                <a:solidFill>
-                  <a:srgbClr val="23272E"/>
-                </a:solidFill>
-                <a:latin typeface="Calibri" pitchFamily="34" charset="0"/>
-                <a:ea typeface="Calibri" pitchFamily="34" charset="-122"/>
-                <a:cs typeface="Calibri" pitchFamily="34" charset="-120"/>
-              </a:rPr>
-              <a:t>2019</a:t>
-            </a:r>
-            <a:endParaRPr lang="en-US" sz="700" dirty="0"/>
-          </a:p>
-        </p:txBody>
-      </p:sp>
-      <p:sp>
-        <p:nvSpPr>
-          <p:cNvPr id="17" name="Shape 15"/>
-          <p:cNvSpPr/>
-          <p:nvPr/>
-        </p:nvSpPr>
-        <p:spPr>
-          <a:xfrm>
-            <a:off x="1365885" y="4726046"/>
-            <a:ext cx="182880" cy="165994"/>
+              <a:rPr lang="en-US" sz="600" b="1" dirty="0">
+                <a:solidFill>
+                  <a:srgbClr val="1E2761"/>
+                </a:solidFill>
+                <a:latin typeface="Calibri" pitchFamily="34" charset="0"/>
+                <a:ea typeface="Calibri" pitchFamily="34" charset="-122"/>
+                <a:cs typeface="Calibri" pitchFamily="34" charset="-120"/>
+              </a:rPr>
+              <a:t>38</a:t>
+            </a:r>
+            <a:endParaRPr lang="en-US" sz="600" dirty="0"/>
+          </a:p>
+        </p:txBody>
+      </p:sp>
+      <p:sp>
+        <p:nvSpPr>
+          <p:cNvPr id="18" name="Shape 16"/>
+          <p:cNvSpPr/>
+          <p:nvPr/>
+        </p:nvSpPr>
+        <p:spPr>
+          <a:xfrm>
+            <a:off x="1413320" y="4636985"/>
+            <a:ext cx="173736" cy="136183"/>
           </a:xfrm>
           <a:prstGeom prst="rect">
             <a:avLst/>
@@ -1418,53 +1438,53 @@
       </p:sp>
       <p:sp>
         <p:nvSpPr>
-          <p:cNvPr id="18" name="Text 16"/>
-          <p:cNvSpPr/>
-          <p:nvPr/>
-        </p:nvSpPr>
-        <p:spPr>
-          <a:xfrm>
-            <a:off x="1291590" y="4928616"/>
-            <a:ext cx="331470" cy="182880"/>
-          </a:xfrm>
-          <a:prstGeom prst="rect">
-            <a:avLst/>
-          </a:prstGeom>
-          <a:noFill/>
-          <a:ln/>
-        </p:spPr>
-        <p:txBody>
-          <a:bodyPr wrap="square" lIns="0" tIns="0" rIns="0" bIns="0" rtlCol="0" anchor="t"/>
+          <p:cNvPr id="19" name="Text 17"/>
+          <p:cNvSpPr/>
+          <p:nvPr/>
+        </p:nvSpPr>
+        <p:spPr>
+          <a:xfrm>
+            <a:off x="1116140" y="4417529"/>
+            <a:ext cx="768096" cy="137160"/>
+          </a:xfrm>
+          <a:prstGeom prst="rect">
+            <a:avLst/>
+          </a:prstGeom>
+          <a:noFill/>
+          <a:ln/>
+        </p:spPr>
+        <p:txBody>
+          <a:bodyPr wrap="square" lIns="0" tIns="0" rIns="0" bIns="0" rtlCol="0" anchor="b"/>
           <a:lstStyle/>
           <a:p>
             <a:pPr algn="ctr" indent="0" marL="0">
               <a:buNone/>
             </a:pPr>
             <a:r>
-              <a:rPr lang="en-US" sz="700" dirty="0">
-                <a:solidFill>
-                  <a:srgbClr val="23272E"/>
-                </a:solidFill>
-                <a:latin typeface="Calibri" pitchFamily="34" charset="0"/>
-                <a:ea typeface="Calibri" pitchFamily="34" charset="-122"/>
-                <a:cs typeface="Calibri" pitchFamily="34" charset="-120"/>
-              </a:rPr>
-              <a:t>2020</a:t>
-            </a:r>
-            <a:endParaRPr lang="en-US" sz="700" dirty="0"/>
-          </a:p>
-        </p:txBody>
-      </p:sp>
-      <p:sp>
-        <p:nvSpPr>
-          <p:cNvPr id="19" name="Shape 17"/>
-          <p:cNvSpPr/>
-          <p:nvPr/>
-        </p:nvSpPr>
-        <p:spPr>
-          <a:xfrm>
-            <a:off x="1697355" y="4580677"/>
-            <a:ext cx="182880" cy="311363"/>
+              <a:rPr lang="en-US" sz="600" b="1" dirty="0">
+                <a:solidFill>
+                  <a:srgbClr val="1E2761"/>
+                </a:solidFill>
+                <a:latin typeface="Calibri" pitchFamily="34" charset="0"/>
+                <a:ea typeface="Calibri" pitchFamily="34" charset="-122"/>
+                <a:cs typeface="Calibri" pitchFamily="34" charset="-120"/>
+              </a:rPr>
+              <a:t>1,167</a:t>
+            </a:r>
+            <a:endParaRPr lang="en-US" sz="600" dirty="0"/>
+          </a:p>
+        </p:txBody>
+      </p:sp>
+      <p:sp>
+        <p:nvSpPr>
+          <p:cNvPr id="20" name="Shape 18"/>
+          <p:cNvSpPr/>
+          <p:nvPr/>
+        </p:nvSpPr>
+        <p:spPr>
+          <a:xfrm>
+            <a:off x="1773365" y="4517723"/>
+            <a:ext cx="173736" cy="255445"/>
           </a:xfrm>
           <a:prstGeom prst="rect">
             <a:avLst/>
@@ -1477,53 +1497,53 @@
       </p:sp>
       <p:sp>
         <p:nvSpPr>
-          <p:cNvPr id="20" name="Text 18"/>
-          <p:cNvSpPr/>
-          <p:nvPr/>
-        </p:nvSpPr>
-        <p:spPr>
-          <a:xfrm>
-            <a:off x="1623060" y="4928616"/>
-            <a:ext cx="331470" cy="182880"/>
-          </a:xfrm>
-          <a:prstGeom prst="rect">
-            <a:avLst/>
-          </a:prstGeom>
-          <a:noFill/>
-          <a:ln/>
-        </p:spPr>
-        <p:txBody>
-          <a:bodyPr wrap="square" lIns="0" tIns="0" rIns="0" bIns="0" rtlCol="0" anchor="t"/>
+          <p:cNvPr id="21" name="Text 19"/>
+          <p:cNvSpPr/>
+          <p:nvPr/>
+        </p:nvSpPr>
+        <p:spPr>
+          <a:xfrm>
+            <a:off x="1476185" y="4298267"/>
+            <a:ext cx="768096" cy="137160"/>
+          </a:xfrm>
+          <a:prstGeom prst="rect">
+            <a:avLst/>
+          </a:prstGeom>
+          <a:noFill/>
+          <a:ln/>
+        </p:spPr>
+        <p:txBody>
+          <a:bodyPr wrap="square" lIns="0" tIns="0" rIns="0" bIns="0" rtlCol="0" anchor="b"/>
           <a:lstStyle/>
           <a:p>
             <a:pPr algn="ctr" indent="0" marL="0">
               <a:buNone/>
             </a:pPr>
             <a:r>
-              <a:rPr lang="en-US" sz="700" dirty="0">
-                <a:solidFill>
-                  <a:srgbClr val="23272E"/>
-                </a:solidFill>
-                <a:latin typeface="Calibri" pitchFamily="34" charset="0"/>
-                <a:ea typeface="Calibri" pitchFamily="34" charset="-122"/>
-                <a:cs typeface="Calibri" pitchFamily="34" charset="-120"/>
-              </a:rPr>
-              <a:t>2021</a:t>
-            </a:r>
-            <a:endParaRPr lang="en-US" sz="700" dirty="0"/>
-          </a:p>
-        </p:txBody>
-      </p:sp>
-      <p:sp>
-        <p:nvSpPr>
-          <p:cNvPr id="21" name="Shape 19"/>
-          <p:cNvSpPr/>
-          <p:nvPr/>
-        </p:nvSpPr>
-        <p:spPr>
-          <a:xfrm>
-            <a:off x="2028825" y="4579539"/>
-            <a:ext cx="182880" cy="312501"/>
+              <a:rPr lang="en-US" sz="600" b="1" dirty="0">
+                <a:solidFill>
+                  <a:srgbClr val="1E2761"/>
+                </a:solidFill>
+                <a:latin typeface="Calibri" pitchFamily="34" charset="0"/>
+                <a:ea typeface="Calibri" pitchFamily="34" charset="-122"/>
+                <a:cs typeface="Calibri" pitchFamily="34" charset="-120"/>
+              </a:rPr>
+              <a:t>2,189</a:t>
+            </a:r>
+            <a:endParaRPr lang="en-US" sz="600" dirty="0"/>
+          </a:p>
+        </p:txBody>
+      </p:sp>
+      <p:sp>
+        <p:nvSpPr>
+          <p:cNvPr id="22" name="Shape 20"/>
+          <p:cNvSpPr/>
+          <p:nvPr/>
+        </p:nvSpPr>
+        <p:spPr>
+          <a:xfrm>
+            <a:off x="2133410" y="4516789"/>
+            <a:ext cx="173736" cy="256379"/>
           </a:xfrm>
           <a:prstGeom prst="rect">
             <a:avLst/>
@@ -1536,53 +1556,53 @@
       </p:sp>
       <p:sp>
         <p:nvSpPr>
-          <p:cNvPr id="22" name="Text 20"/>
-          <p:cNvSpPr/>
-          <p:nvPr/>
-        </p:nvSpPr>
-        <p:spPr>
-          <a:xfrm>
-            <a:off x="1954530" y="4928616"/>
-            <a:ext cx="331470" cy="182880"/>
-          </a:xfrm>
-          <a:prstGeom prst="rect">
-            <a:avLst/>
-          </a:prstGeom>
-          <a:noFill/>
-          <a:ln/>
-        </p:spPr>
-        <p:txBody>
-          <a:bodyPr wrap="square" lIns="0" tIns="0" rIns="0" bIns="0" rtlCol="0" anchor="t"/>
+          <p:cNvPr id="23" name="Text 21"/>
+          <p:cNvSpPr/>
+          <p:nvPr/>
+        </p:nvSpPr>
+        <p:spPr>
+          <a:xfrm>
+            <a:off x="1836230" y="4297333"/>
+            <a:ext cx="768096" cy="137160"/>
+          </a:xfrm>
+          <a:prstGeom prst="rect">
+            <a:avLst/>
+          </a:prstGeom>
+          <a:noFill/>
+          <a:ln/>
+        </p:spPr>
+        <p:txBody>
+          <a:bodyPr wrap="square" lIns="0" tIns="0" rIns="0" bIns="0" rtlCol="0" anchor="b"/>
           <a:lstStyle/>
           <a:p>
             <a:pPr algn="ctr" indent="0" marL="0">
               <a:buNone/>
             </a:pPr>
             <a:r>
-              <a:rPr lang="en-US" sz="700" dirty="0">
-                <a:solidFill>
-                  <a:srgbClr val="23272E"/>
-                </a:solidFill>
-                <a:latin typeface="Calibri" pitchFamily="34" charset="0"/>
-                <a:ea typeface="Calibri" pitchFamily="34" charset="-122"/>
-                <a:cs typeface="Calibri" pitchFamily="34" charset="-120"/>
-              </a:rPr>
-              <a:t>2022</a:t>
-            </a:r>
-            <a:endParaRPr lang="en-US" sz="700" dirty="0"/>
-          </a:p>
-        </p:txBody>
-      </p:sp>
-      <p:sp>
-        <p:nvSpPr>
-          <p:cNvPr id="23" name="Shape 21"/>
-          <p:cNvSpPr/>
-          <p:nvPr/>
-        </p:nvSpPr>
-        <p:spPr>
-          <a:xfrm>
-            <a:off x="2360295" y="3975445"/>
-            <a:ext cx="182880" cy="916595"/>
+              <a:rPr lang="en-US" sz="600" b="1" dirty="0">
+                <a:solidFill>
+                  <a:srgbClr val="1E2761"/>
+                </a:solidFill>
+                <a:latin typeface="Calibri" pitchFamily="34" charset="0"/>
+                <a:ea typeface="Calibri" pitchFamily="34" charset="-122"/>
+                <a:cs typeface="Calibri" pitchFamily="34" charset="-120"/>
+              </a:rPr>
+              <a:t>2,197</a:t>
+            </a:r>
+            <a:endParaRPr lang="en-US" sz="600" dirty="0"/>
+          </a:p>
+        </p:txBody>
+      </p:sp>
+      <p:sp>
+        <p:nvSpPr>
+          <p:cNvPr id="24" name="Shape 22"/>
+          <p:cNvSpPr/>
+          <p:nvPr/>
+        </p:nvSpPr>
+        <p:spPr>
+          <a:xfrm>
+            <a:off x="2493455" y="4021186"/>
+            <a:ext cx="173736" cy="751982"/>
           </a:xfrm>
           <a:prstGeom prst="rect">
             <a:avLst/>
@@ -1595,53 +1615,53 @@
       </p:sp>
       <p:sp>
         <p:nvSpPr>
-          <p:cNvPr id="24" name="Text 22"/>
-          <p:cNvSpPr/>
-          <p:nvPr/>
-        </p:nvSpPr>
-        <p:spPr>
-          <a:xfrm>
-            <a:off x="2286000" y="4928616"/>
-            <a:ext cx="331470" cy="182880"/>
-          </a:xfrm>
-          <a:prstGeom prst="rect">
-            <a:avLst/>
-          </a:prstGeom>
-          <a:noFill/>
-          <a:ln/>
-        </p:spPr>
-        <p:txBody>
-          <a:bodyPr wrap="square" lIns="0" tIns="0" rIns="0" bIns="0" rtlCol="0" anchor="t"/>
+          <p:cNvPr id="25" name="Text 23"/>
+          <p:cNvSpPr/>
+          <p:nvPr/>
+        </p:nvSpPr>
+        <p:spPr>
+          <a:xfrm>
+            <a:off x="2196275" y="3801730"/>
+            <a:ext cx="768096" cy="137160"/>
+          </a:xfrm>
+          <a:prstGeom prst="rect">
+            <a:avLst/>
+          </a:prstGeom>
+          <a:noFill/>
+          <a:ln/>
+        </p:spPr>
+        <p:txBody>
+          <a:bodyPr wrap="square" lIns="0" tIns="0" rIns="0" bIns="0" rtlCol="0" anchor="b"/>
           <a:lstStyle/>
           <a:p>
             <a:pPr algn="ctr" indent="0" marL="0">
               <a:buNone/>
             </a:pPr>
             <a:r>
-              <a:rPr lang="en-US" sz="700" dirty="0">
-                <a:solidFill>
-                  <a:srgbClr val="23272E"/>
-                </a:solidFill>
-                <a:latin typeface="Calibri" pitchFamily="34" charset="0"/>
-                <a:ea typeface="Calibri" pitchFamily="34" charset="-122"/>
-                <a:cs typeface="Calibri" pitchFamily="34" charset="-120"/>
-              </a:rPr>
-              <a:t>2023</a:t>
-            </a:r>
-            <a:endParaRPr lang="en-US" sz="700" dirty="0"/>
-          </a:p>
-        </p:txBody>
-      </p:sp>
-      <p:sp>
-        <p:nvSpPr>
-          <p:cNvPr id="25" name="Shape 23"/>
-          <p:cNvSpPr/>
-          <p:nvPr/>
-        </p:nvSpPr>
-        <p:spPr>
-          <a:xfrm>
-            <a:off x="2691765" y="3699500"/>
-            <a:ext cx="182880" cy="1192540"/>
+              <a:rPr lang="en-US" sz="600" b="1" dirty="0">
+                <a:solidFill>
+                  <a:srgbClr val="1E2761"/>
+                </a:solidFill>
+                <a:latin typeface="Calibri" pitchFamily="34" charset="0"/>
+                <a:ea typeface="Calibri" pitchFamily="34" charset="-122"/>
+                <a:cs typeface="Calibri" pitchFamily="34" charset="-120"/>
+              </a:rPr>
+              <a:t>6,444</a:t>
+            </a:r>
+            <a:endParaRPr lang="en-US" sz="600" dirty="0"/>
+          </a:p>
+        </p:txBody>
+      </p:sp>
+      <p:sp>
+        <p:nvSpPr>
+          <p:cNvPr id="26" name="Shape 24"/>
+          <p:cNvSpPr/>
+          <p:nvPr/>
+        </p:nvSpPr>
+        <p:spPr>
+          <a:xfrm>
+            <a:off x="2853500" y="3794798"/>
+            <a:ext cx="173736" cy="978370"/>
           </a:xfrm>
           <a:prstGeom prst="rect">
             <a:avLst/>
@@ -1654,53 +1674,53 @@
       </p:sp>
       <p:sp>
         <p:nvSpPr>
-          <p:cNvPr id="26" name="Text 24"/>
-          <p:cNvSpPr/>
-          <p:nvPr/>
-        </p:nvSpPr>
-        <p:spPr>
-          <a:xfrm>
-            <a:off x="2617470" y="4928616"/>
-            <a:ext cx="331470" cy="182880"/>
-          </a:xfrm>
-          <a:prstGeom prst="rect">
-            <a:avLst/>
-          </a:prstGeom>
-          <a:noFill/>
-          <a:ln/>
-        </p:spPr>
-        <p:txBody>
-          <a:bodyPr wrap="square" lIns="0" tIns="0" rIns="0" bIns="0" rtlCol="0" anchor="t"/>
+          <p:cNvPr id="27" name="Text 25"/>
+          <p:cNvSpPr/>
+          <p:nvPr/>
+        </p:nvSpPr>
+        <p:spPr>
+          <a:xfrm>
+            <a:off x="2556320" y="3575342"/>
+            <a:ext cx="768096" cy="137160"/>
+          </a:xfrm>
+          <a:prstGeom prst="rect">
+            <a:avLst/>
+          </a:prstGeom>
+          <a:noFill/>
+          <a:ln/>
+        </p:spPr>
+        <p:txBody>
+          <a:bodyPr wrap="square" lIns="0" tIns="0" rIns="0" bIns="0" rtlCol="0" anchor="b"/>
           <a:lstStyle/>
           <a:p>
             <a:pPr algn="ctr" indent="0" marL="0">
               <a:buNone/>
             </a:pPr>
             <a:r>
-              <a:rPr lang="en-US" sz="700" dirty="0">
-                <a:solidFill>
-                  <a:srgbClr val="23272E"/>
-                </a:solidFill>
-                <a:latin typeface="Calibri" pitchFamily="34" charset="0"/>
-                <a:ea typeface="Calibri" pitchFamily="34" charset="-122"/>
-                <a:cs typeface="Calibri" pitchFamily="34" charset="-120"/>
-              </a:rPr>
-              <a:t>2024</a:t>
-            </a:r>
-            <a:endParaRPr lang="en-US" sz="700" dirty="0"/>
-          </a:p>
-        </p:txBody>
-      </p:sp>
-      <p:sp>
-        <p:nvSpPr>
-          <p:cNvPr id="27" name="Shape 25"/>
-          <p:cNvSpPr/>
-          <p:nvPr/>
-        </p:nvSpPr>
-        <p:spPr>
-          <a:xfrm>
-            <a:off x="3023235" y="4000622"/>
-            <a:ext cx="182880" cy="891418"/>
+              <a:rPr lang="en-US" sz="600" b="1" dirty="0">
+                <a:solidFill>
+                  <a:srgbClr val="1E2761"/>
+                </a:solidFill>
+                <a:latin typeface="Calibri" pitchFamily="34" charset="0"/>
+                <a:ea typeface="Calibri" pitchFamily="34" charset="-122"/>
+                <a:cs typeface="Calibri" pitchFamily="34" charset="-120"/>
+              </a:rPr>
+              <a:t>8,384</a:t>
+            </a:r>
+            <a:endParaRPr lang="en-US" sz="600" dirty="0"/>
+          </a:p>
+        </p:txBody>
+      </p:sp>
+      <p:sp>
+        <p:nvSpPr>
+          <p:cNvPr id="28" name="Shape 26"/>
+          <p:cNvSpPr/>
+          <p:nvPr/>
+        </p:nvSpPr>
+        <p:spPr>
+          <a:xfrm>
+            <a:off x="3213545" y="4041841"/>
+            <a:ext cx="173736" cy="731327"/>
           </a:xfrm>
           <a:prstGeom prst="rect">
             <a:avLst/>
@@ -1713,53 +1733,53 @@
       </p:sp>
       <p:sp>
         <p:nvSpPr>
-          <p:cNvPr id="28" name="Text 26"/>
-          <p:cNvSpPr/>
-          <p:nvPr/>
-        </p:nvSpPr>
-        <p:spPr>
-          <a:xfrm>
-            <a:off x="2948940" y="4928616"/>
-            <a:ext cx="331470" cy="182880"/>
-          </a:xfrm>
-          <a:prstGeom prst="rect">
-            <a:avLst/>
-          </a:prstGeom>
-          <a:noFill/>
-          <a:ln/>
-        </p:spPr>
-        <p:txBody>
-          <a:bodyPr wrap="square" lIns="0" tIns="0" rIns="0" bIns="0" rtlCol="0" anchor="t"/>
+          <p:cNvPr id="29" name="Text 27"/>
+          <p:cNvSpPr/>
+          <p:nvPr/>
+        </p:nvSpPr>
+        <p:spPr>
+          <a:xfrm>
+            <a:off x="2916365" y="3794028"/>
+            <a:ext cx="768096" cy="137160"/>
+          </a:xfrm>
+          <a:prstGeom prst="rect">
+            <a:avLst/>
+          </a:prstGeom>
+          <a:noFill/>
+          <a:ln/>
+        </p:spPr>
+        <p:txBody>
+          <a:bodyPr wrap="square" lIns="0" tIns="0" rIns="0" bIns="0" rtlCol="0" anchor="b"/>
           <a:lstStyle/>
           <a:p>
             <a:pPr algn="ctr" indent="0" marL="0">
               <a:buNone/>
             </a:pPr>
             <a:r>
-              <a:rPr lang="en-US" sz="700" dirty="0">
-                <a:solidFill>
-                  <a:srgbClr val="23272E"/>
-                </a:solidFill>
-                <a:latin typeface="Calibri" pitchFamily="34" charset="0"/>
-                <a:ea typeface="Calibri" pitchFamily="34" charset="-122"/>
-                <a:cs typeface="Calibri" pitchFamily="34" charset="-120"/>
-              </a:rPr>
-              <a:t>2025</a:t>
-            </a:r>
-            <a:endParaRPr lang="en-US" sz="700" dirty="0"/>
-          </a:p>
-        </p:txBody>
-      </p:sp>
-      <p:sp>
-        <p:nvSpPr>
-          <p:cNvPr id="29" name="Shape 27"/>
-          <p:cNvSpPr/>
-          <p:nvPr/>
-        </p:nvSpPr>
-        <p:spPr>
-          <a:xfrm>
-            <a:off x="3354705" y="3907881"/>
-            <a:ext cx="182880" cy="984159"/>
+              <a:rPr lang="en-US" sz="600" b="1" dirty="0">
+                <a:solidFill>
+                  <a:srgbClr val="1E2761"/>
+                </a:solidFill>
+                <a:latin typeface="Calibri" pitchFamily="34" charset="0"/>
+                <a:ea typeface="Calibri" pitchFamily="34" charset="-122"/>
+                <a:cs typeface="Calibri" pitchFamily="34" charset="-120"/>
+              </a:rPr>
+              <a:t>6,267</a:t>
+            </a:r>
+            <a:endParaRPr lang="en-US" sz="600" dirty="0"/>
+          </a:p>
+        </p:txBody>
+      </p:sp>
+      <p:sp>
+        <p:nvSpPr>
+          <p:cNvPr id="30" name="Shape 28"/>
+          <p:cNvSpPr/>
+          <p:nvPr/>
+        </p:nvSpPr>
+        <p:spPr>
+          <a:xfrm>
+            <a:off x="3573590" y="3965756"/>
+            <a:ext cx="173736" cy="807412"/>
           </a:xfrm>
           <a:prstGeom prst="rect">
             <a:avLst/>
@@ -1772,53 +1792,53 @@
       </p:sp>
       <p:sp>
         <p:nvSpPr>
-          <p:cNvPr id="30" name="Text 28"/>
-          <p:cNvSpPr/>
-          <p:nvPr/>
-        </p:nvSpPr>
-        <p:spPr>
-          <a:xfrm>
-            <a:off x="3280410" y="4928616"/>
-            <a:ext cx="331470" cy="182880"/>
-          </a:xfrm>
-          <a:prstGeom prst="rect">
-            <a:avLst/>
-          </a:prstGeom>
-          <a:noFill/>
-          <a:ln/>
-        </p:spPr>
-        <p:txBody>
-          <a:bodyPr wrap="square" lIns="0" tIns="0" rIns="0" bIns="0" rtlCol="0" anchor="t"/>
+          <p:cNvPr id="31" name="Text 29"/>
+          <p:cNvSpPr/>
+          <p:nvPr/>
+        </p:nvSpPr>
+        <p:spPr>
+          <a:xfrm>
+            <a:off x="3276410" y="3659246"/>
+            <a:ext cx="768096" cy="137160"/>
+          </a:xfrm>
+          <a:prstGeom prst="rect">
+            <a:avLst/>
+          </a:prstGeom>
+          <a:noFill/>
+          <a:ln/>
+        </p:spPr>
+        <p:txBody>
+          <a:bodyPr wrap="square" lIns="0" tIns="0" rIns="0" bIns="0" rtlCol="0" anchor="b"/>
           <a:lstStyle/>
           <a:p>
             <a:pPr algn="ctr" indent="0" marL="0">
               <a:buNone/>
             </a:pPr>
             <a:r>
-              <a:rPr lang="en-US" sz="700" dirty="0">
-                <a:solidFill>
-                  <a:srgbClr val="23272E"/>
-                </a:solidFill>
-                <a:latin typeface="Calibri" pitchFamily="34" charset="0"/>
-                <a:ea typeface="Calibri" pitchFamily="34" charset="-122"/>
-                <a:cs typeface="Calibri" pitchFamily="34" charset="-120"/>
-              </a:rPr>
-              <a:t>2026</a:t>
-            </a:r>
-            <a:endParaRPr lang="en-US" sz="700" dirty="0"/>
-          </a:p>
-        </p:txBody>
-      </p:sp>
-      <p:sp>
-        <p:nvSpPr>
-          <p:cNvPr id="31" name="Shape 29"/>
+              <a:rPr lang="en-US" sz="600" b="1" dirty="0">
+                <a:solidFill>
+                  <a:srgbClr val="1E2761"/>
+                </a:solidFill>
+                <a:latin typeface="Calibri" pitchFamily="34" charset="0"/>
+                <a:ea typeface="Calibri" pitchFamily="34" charset="-122"/>
+                <a:cs typeface="Calibri" pitchFamily="34" charset="-120"/>
+              </a:rPr>
+              <a:t>6,919</a:t>
+            </a:r>
+            <a:endParaRPr lang="en-US" sz="600" dirty="0"/>
+          </a:p>
+        </p:txBody>
+      </p:sp>
+      <p:sp>
+        <p:nvSpPr>
+          <p:cNvPr id="32" name="Shape 30"/>
           <p:cNvSpPr/>
           <p:nvPr/>
         </p:nvSpPr>
         <p:spPr>
           <a:xfrm flipV="1">
-            <a:off x="1125855" y="4789627"/>
-            <a:ext cx="331470" cy="98857"/>
+            <a:off x="1140143" y="4689148"/>
+            <a:ext cx="360045" cy="81103"/>
           </a:xfrm>
           <a:prstGeom prst="line">
             <a:avLst/>
@@ -1834,14 +1854,14 @@
       </p:sp>
       <p:sp>
         <p:nvSpPr>
-          <p:cNvPr id="32" name="Shape 30"/>
+          <p:cNvPr id="33" name="Shape 31"/>
           <p:cNvSpPr/>
           <p:nvPr/>
         </p:nvSpPr>
         <p:spPr>
           <a:xfrm flipV="1">
-            <a:off x="1457325" y="4703572"/>
-            <a:ext cx="331470" cy="86055"/>
+            <a:off x="1500188" y="4618547"/>
+            <a:ext cx="360045" cy="70600"/>
           </a:xfrm>
           <a:prstGeom prst="line">
             <a:avLst/>
@@ -1857,14 +1877,14 @@
       </p:sp>
       <p:sp>
         <p:nvSpPr>
-          <p:cNvPr id="33" name="Shape 31"/>
+          <p:cNvPr id="34" name="Shape 32"/>
           <p:cNvSpPr/>
           <p:nvPr/>
         </p:nvSpPr>
         <p:spPr>
           <a:xfrm flipV="1">
-            <a:off x="1788795" y="4672990"/>
-            <a:ext cx="331470" cy="30582"/>
+            <a:off x="1860233" y="4593458"/>
+            <a:ext cx="360045" cy="25089"/>
           </a:xfrm>
           <a:prstGeom prst="line">
             <a:avLst/>
@@ -1880,14 +1900,14 @@
       </p:sp>
       <p:sp>
         <p:nvSpPr>
-          <p:cNvPr id="34" name="Shape 32"/>
+          <p:cNvPr id="35" name="Shape 33"/>
           <p:cNvSpPr/>
           <p:nvPr/>
         </p:nvSpPr>
         <p:spPr>
           <a:xfrm flipV="1">
-            <a:off x="2120265" y="4074160"/>
-            <a:ext cx="331470" cy="598830"/>
+            <a:off x="2220278" y="4102173"/>
+            <a:ext cx="360045" cy="491285"/>
           </a:xfrm>
           <a:prstGeom prst="line">
             <a:avLst/>
@@ -1903,14 +1923,14 @@
       </p:sp>
       <p:sp>
         <p:nvSpPr>
-          <p:cNvPr id="35" name="Shape 33"/>
+          <p:cNvPr id="36" name="Shape 34"/>
           <p:cNvSpPr/>
           <p:nvPr/>
         </p:nvSpPr>
         <p:spPr>
           <a:xfrm flipV="1">
-            <a:off x="2451735" y="3734206"/>
-            <a:ext cx="331470" cy="339954"/>
+            <a:off x="2580323" y="3823272"/>
+            <a:ext cx="360045" cy="278901"/>
           </a:xfrm>
           <a:prstGeom prst="line">
             <a:avLst/>
@@ -1926,14 +1946,14 @@
       </p:sp>
       <p:sp>
         <p:nvSpPr>
-          <p:cNvPr id="36" name="Shape 34"/>
-          <p:cNvSpPr/>
-          <p:nvPr/>
-        </p:nvSpPr>
-        <p:spPr>
-          <a:xfrm>
-            <a:off x="2783205" y="3734206"/>
-            <a:ext cx="331470" cy="231851"/>
+          <p:cNvPr id="37" name="Shape 35"/>
+          <p:cNvSpPr/>
+          <p:nvPr/>
+        </p:nvSpPr>
+        <p:spPr>
+          <a:xfrm>
+            <a:off x="2940368" y="3823272"/>
+            <a:ext cx="360045" cy="190213"/>
           </a:xfrm>
           <a:prstGeom prst="line">
             <a:avLst/>
@@ -1949,14 +1969,14 @@
       </p:sp>
       <p:sp>
         <p:nvSpPr>
-          <p:cNvPr id="37" name="Shape 35"/>
+          <p:cNvPr id="38" name="Shape 36"/>
           <p:cNvSpPr/>
           <p:nvPr/>
         </p:nvSpPr>
         <p:spPr>
           <a:xfrm flipV="1">
-            <a:off x="3114675" y="3801770"/>
-            <a:ext cx="331470" cy="164287"/>
+            <a:off x="3300413" y="3878702"/>
+            <a:ext cx="360045" cy="134783"/>
           </a:xfrm>
           <a:prstGeom prst="line">
             <a:avLst/>
@@ -1972,14 +1992,14 @@
       </p:sp>
       <p:sp>
         <p:nvSpPr>
-          <p:cNvPr id="38" name="Shape 36"/>
-          <p:cNvSpPr/>
-          <p:nvPr/>
-        </p:nvSpPr>
-        <p:spPr>
-          <a:xfrm>
-            <a:off x="1086993" y="4849622"/>
-            <a:ext cx="77724" cy="77724"/>
+          <p:cNvPr id="39" name="Shape 37"/>
+          <p:cNvSpPr/>
+          <p:nvPr/>
+        </p:nvSpPr>
+        <p:spPr>
+          <a:xfrm>
+            <a:off x="1103567" y="4733675"/>
+            <a:ext cx="73152" cy="73152"/>
           </a:xfrm>
           <a:prstGeom prst="ellipse">
             <a:avLst/>
@@ -1997,14 +2017,14 @@
       </p:sp>
       <p:sp>
         <p:nvSpPr>
-          <p:cNvPr id="39" name="Shape 37"/>
-          <p:cNvSpPr/>
-          <p:nvPr/>
-        </p:nvSpPr>
-        <p:spPr>
-          <a:xfrm>
-            <a:off x="1418463" y="4750765"/>
-            <a:ext cx="77724" cy="77724"/>
+          <p:cNvPr id="40" name="Shape 38"/>
+          <p:cNvSpPr/>
+          <p:nvPr/>
+        </p:nvSpPr>
+        <p:spPr>
+          <a:xfrm>
+            <a:off x="1463612" y="4652572"/>
+            <a:ext cx="73152" cy="73152"/>
           </a:xfrm>
           <a:prstGeom prst="ellipse">
             <a:avLst/>
@@ -2022,14 +2042,14 @@
       </p:sp>
       <p:sp>
         <p:nvSpPr>
-          <p:cNvPr id="40" name="Shape 38"/>
-          <p:cNvSpPr/>
-          <p:nvPr/>
-        </p:nvSpPr>
-        <p:spPr>
-          <a:xfrm>
-            <a:off x="1749933" y="4664710"/>
-            <a:ext cx="77724" cy="77724"/>
+          <p:cNvPr id="41" name="Shape 39"/>
+          <p:cNvSpPr/>
+          <p:nvPr/>
+        </p:nvSpPr>
+        <p:spPr>
+          <a:xfrm>
+            <a:off x="1823657" y="4581971"/>
+            <a:ext cx="73152" cy="73152"/>
           </a:xfrm>
           <a:prstGeom prst="ellipse">
             <a:avLst/>
@@ -2047,14 +2067,14 @@
       </p:sp>
       <p:sp>
         <p:nvSpPr>
-          <p:cNvPr id="41" name="Shape 39"/>
-          <p:cNvSpPr/>
-          <p:nvPr/>
-        </p:nvSpPr>
-        <p:spPr>
-          <a:xfrm>
-            <a:off x="2081403" y="4634128"/>
-            <a:ext cx="77724" cy="77724"/>
+          <p:cNvPr id="42" name="Shape 40"/>
+          <p:cNvSpPr/>
+          <p:nvPr/>
+        </p:nvSpPr>
+        <p:spPr>
+          <a:xfrm>
+            <a:off x="2183702" y="4556882"/>
+            <a:ext cx="73152" cy="73152"/>
           </a:xfrm>
           <a:prstGeom prst="ellipse">
             <a:avLst/>
@@ -2072,14 +2092,14 @@
       </p:sp>
       <p:sp>
         <p:nvSpPr>
-          <p:cNvPr id="42" name="Shape 40"/>
-          <p:cNvSpPr/>
-          <p:nvPr/>
-        </p:nvSpPr>
-        <p:spPr>
-          <a:xfrm>
-            <a:off x="2412873" y="4035298"/>
-            <a:ext cx="77724" cy="77724"/>
+          <p:cNvPr id="43" name="Shape 41"/>
+          <p:cNvSpPr/>
+          <p:nvPr/>
+        </p:nvSpPr>
+        <p:spPr>
+          <a:xfrm>
+            <a:off x="2543747" y="4065597"/>
+            <a:ext cx="73152" cy="73152"/>
           </a:xfrm>
           <a:prstGeom prst="ellipse">
             <a:avLst/>
@@ -2097,14 +2117,14 @@
       </p:sp>
       <p:sp>
         <p:nvSpPr>
-          <p:cNvPr id="43" name="Shape 41"/>
-          <p:cNvSpPr/>
-          <p:nvPr/>
-        </p:nvSpPr>
-        <p:spPr>
-          <a:xfrm>
-            <a:off x="2744343" y="3695344"/>
-            <a:ext cx="77724" cy="77724"/>
+          <p:cNvPr id="44" name="Shape 42"/>
+          <p:cNvSpPr/>
+          <p:nvPr/>
+        </p:nvSpPr>
+        <p:spPr>
+          <a:xfrm>
+            <a:off x="2903792" y="3786696"/>
+            <a:ext cx="73152" cy="73152"/>
           </a:xfrm>
           <a:prstGeom prst="ellipse">
             <a:avLst/>
@@ -2122,14 +2142,14 @@
       </p:sp>
       <p:sp>
         <p:nvSpPr>
-          <p:cNvPr id="44" name="Shape 42"/>
-          <p:cNvSpPr/>
-          <p:nvPr/>
-        </p:nvSpPr>
-        <p:spPr>
-          <a:xfrm>
-            <a:off x="3075813" y="3927196"/>
-            <a:ext cx="77724" cy="77724"/>
+          <p:cNvPr id="45" name="Shape 43"/>
+          <p:cNvSpPr/>
+          <p:nvPr/>
+        </p:nvSpPr>
+        <p:spPr>
+          <a:xfrm>
+            <a:off x="3263837" y="3976908"/>
+            <a:ext cx="73152" cy="73152"/>
           </a:xfrm>
           <a:prstGeom prst="ellipse">
             <a:avLst/>
@@ -2147,14 +2167,14 @@
       </p:sp>
       <p:sp>
         <p:nvSpPr>
-          <p:cNvPr id="45" name="Shape 43"/>
-          <p:cNvSpPr/>
-          <p:nvPr/>
-        </p:nvSpPr>
-        <p:spPr>
-          <a:xfrm>
-            <a:off x="3407283" y="3762908"/>
-            <a:ext cx="77724" cy="77724"/>
+          <p:cNvPr id="46" name="Shape 44"/>
+          <p:cNvSpPr/>
+          <p:nvPr/>
+        </p:nvSpPr>
+        <p:spPr>
+          <a:xfrm>
+            <a:off x="3623882" y="3842126"/>
+            <a:ext cx="73152" cy="73152"/>
           </a:xfrm>
           <a:prstGeom prst="ellipse">
             <a:avLst/>
@@ -2172,34 +2192,658 @@
       </p:sp>
       <p:sp>
         <p:nvSpPr>
-          <p:cNvPr id="46" name="Shape 44"/>
-          <p:cNvSpPr/>
-          <p:nvPr/>
-        </p:nvSpPr>
-        <p:spPr>
-          <a:xfrm>
-            <a:off x="2490597" y="3496462"/>
-            <a:ext cx="585216" cy="164592"/>
-          </a:xfrm>
-          <a:prstGeom prst="rect">
-            <a:avLst/>
-          </a:prstGeom>
-          <a:solidFill>
-            <a:srgbClr val="FFFFFF"/>
-          </a:solidFill>
-          <a:ln/>
-        </p:spPr>
-      </p:sp>
-      <p:sp>
-        <p:nvSpPr>
           <p:cNvPr id="47" name="Text 45"/>
           <p:cNvSpPr/>
           <p:nvPr/>
         </p:nvSpPr>
         <p:spPr>
           <a:xfrm>
-            <a:off x="2371725" y="3487318"/>
-            <a:ext cx="822960" cy="164592"/>
+            <a:off x="960120" y="4818888"/>
+            <a:ext cx="360045" cy="164592"/>
+          </a:xfrm>
+          <a:prstGeom prst="rect">
+            <a:avLst/>
+          </a:prstGeom>
+          <a:noFill/>
+          <a:ln/>
+        </p:spPr>
+        <p:txBody>
+          <a:bodyPr wrap="square" lIns="0" tIns="0" rIns="0" bIns="0" rtlCol="0" anchor="t"/>
+          <a:lstStyle/>
+          <a:p>
+            <a:pPr algn="ctr" indent="0" marL="0">
+              <a:buNone/>
+            </a:pPr>
+            <a:r>
+              <a:rPr lang="en-US" sz="700" b="1" dirty="0">
+                <a:solidFill>
+                  <a:srgbClr val="23272E"/>
+                </a:solidFill>
+                <a:latin typeface="Calibri" pitchFamily="34" charset="0"/>
+                <a:ea typeface="Calibri" pitchFamily="34" charset="-122"/>
+                <a:cs typeface="Calibri" pitchFamily="34" charset="-120"/>
+              </a:rPr>
+              <a:t>2019</a:t>
+            </a:r>
+            <a:endParaRPr lang="en-US" sz="700" dirty="0"/>
+          </a:p>
+        </p:txBody>
+      </p:sp>
+      <p:sp>
+        <p:nvSpPr>
+          <p:cNvPr id="48" name="Text 46"/>
+          <p:cNvSpPr/>
+          <p:nvPr/>
+        </p:nvSpPr>
+        <p:spPr>
+          <a:xfrm>
+            <a:off x="923544" y="4974336"/>
+            <a:ext cx="433197" cy="146304"/>
+          </a:xfrm>
+          <a:prstGeom prst="rect">
+            <a:avLst/>
+          </a:prstGeom>
+          <a:noFill/>
+          <a:ln/>
+        </p:spPr>
+        <p:txBody>
+          <a:bodyPr wrap="square" lIns="0" tIns="0" rIns="0" bIns="0" rtlCol="0" anchor="t"/>
+          <a:lstStyle/>
+          <a:p>
+            <a:pPr algn="ctr" indent="0" marL="0">
+              <a:buNone/>
+            </a:pPr>
+            <a:r>
+              <a:rPr lang="en-US" sz="550" b="1" dirty="0">
+                <a:solidFill>
+                  <a:srgbClr val="9A6B14"/>
+                </a:solidFill>
+                <a:latin typeface="Calibri" pitchFamily="34" charset="0"/>
+                <a:ea typeface="Calibri" pitchFamily="34" charset="-122"/>
+                <a:cs typeface="Calibri" pitchFamily="34" charset="-120"/>
+              </a:rPr>
+              <a:t>$0.5M</a:t>
+            </a:r>
+            <a:endParaRPr lang="en-US" sz="550" dirty="0"/>
+          </a:p>
+        </p:txBody>
+      </p:sp>
+      <p:sp>
+        <p:nvSpPr>
+          <p:cNvPr id="49" name="Text 47"/>
+          <p:cNvSpPr/>
+          <p:nvPr/>
+        </p:nvSpPr>
+        <p:spPr>
+          <a:xfrm>
+            <a:off x="1320165" y="4818888"/>
+            <a:ext cx="360045" cy="164592"/>
+          </a:xfrm>
+          <a:prstGeom prst="rect">
+            <a:avLst/>
+          </a:prstGeom>
+          <a:noFill/>
+          <a:ln/>
+        </p:spPr>
+        <p:txBody>
+          <a:bodyPr wrap="square" lIns="0" tIns="0" rIns="0" bIns="0" rtlCol="0" anchor="t"/>
+          <a:lstStyle/>
+          <a:p>
+            <a:pPr algn="ctr" indent="0" marL="0">
+              <a:buNone/>
+            </a:pPr>
+            <a:r>
+              <a:rPr lang="en-US" sz="700" b="1" dirty="0">
+                <a:solidFill>
+                  <a:srgbClr val="23272E"/>
+                </a:solidFill>
+                <a:latin typeface="Calibri" pitchFamily="34" charset="0"/>
+                <a:ea typeface="Calibri" pitchFamily="34" charset="-122"/>
+                <a:cs typeface="Calibri" pitchFamily="34" charset="-120"/>
+              </a:rPr>
+              <a:t>2020</a:t>
+            </a:r>
+            <a:endParaRPr lang="en-US" sz="700" dirty="0"/>
+          </a:p>
+        </p:txBody>
+      </p:sp>
+      <p:sp>
+        <p:nvSpPr>
+          <p:cNvPr id="50" name="Text 48"/>
+          <p:cNvSpPr/>
+          <p:nvPr/>
+        </p:nvSpPr>
+        <p:spPr>
+          <a:xfrm>
+            <a:off x="1283589" y="4974336"/>
+            <a:ext cx="433197" cy="146304"/>
+          </a:xfrm>
+          <a:prstGeom prst="rect">
+            <a:avLst/>
+          </a:prstGeom>
+          <a:noFill/>
+          <a:ln/>
+        </p:spPr>
+        <p:txBody>
+          <a:bodyPr wrap="square" lIns="0" tIns="0" rIns="0" bIns="0" rtlCol="0" anchor="t"/>
+          <a:lstStyle/>
+          <a:p>
+            <a:pPr algn="ctr" indent="0" marL="0">
+              <a:buNone/>
+            </a:pPr>
+            <a:r>
+              <a:rPr lang="en-US" sz="550" b="1" dirty="0">
+                <a:solidFill>
+                  <a:srgbClr val="9A6B14"/>
+                </a:solidFill>
+                <a:latin typeface="Calibri" pitchFamily="34" charset="0"/>
+                <a:ea typeface="Calibri" pitchFamily="34" charset="-122"/>
+                <a:cs typeface="Calibri" pitchFamily="34" charset="-120"/>
+              </a:rPr>
+              <a:t>$14.4M</a:t>
+            </a:r>
+            <a:endParaRPr lang="en-US" sz="550" dirty="0"/>
+          </a:p>
+        </p:txBody>
+      </p:sp>
+      <p:sp>
+        <p:nvSpPr>
+          <p:cNvPr id="51" name="Text 49"/>
+          <p:cNvSpPr/>
+          <p:nvPr/>
+        </p:nvSpPr>
+        <p:spPr>
+          <a:xfrm>
+            <a:off x="1680210" y="4818888"/>
+            <a:ext cx="360045" cy="164592"/>
+          </a:xfrm>
+          <a:prstGeom prst="rect">
+            <a:avLst/>
+          </a:prstGeom>
+          <a:noFill/>
+          <a:ln/>
+        </p:spPr>
+        <p:txBody>
+          <a:bodyPr wrap="square" lIns="0" tIns="0" rIns="0" bIns="0" rtlCol="0" anchor="t"/>
+          <a:lstStyle/>
+          <a:p>
+            <a:pPr algn="ctr" indent="0" marL="0">
+              <a:buNone/>
+            </a:pPr>
+            <a:r>
+              <a:rPr lang="en-US" sz="700" b="1" dirty="0">
+                <a:solidFill>
+                  <a:srgbClr val="23272E"/>
+                </a:solidFill>
+                <a:latin typeface="Calibri" pitchFamily="34" charset="0"/>
+                <a:ea typeface="Calibri" pitchFamily="34" charset="-122"/>
+                <a:cs typeface="Calibri" pitchFamily="34" charset="-120"/>
+              </a:rPr>
+              <a:t>2021</a:t>
+            </a:r>
+            <a:endParaRPr lang="en-US" sz="700" dirty="0"/>
+          </a:p>
+        </p:txBody>
+      </p:sp>
+      <p:sp>
+        <p:nvSpPr>
+          <p:cNvPr id="52" name="Text 50"/>
+          <p:cNvSpPr/>
+          <p:nvPr/>
+        </p:nvSpPr>
+        <p:spPr>
+          <a:xfrm>
+            <a:off x="1643634" y="4974336"/>
+            <a:ext cx="433197" cy="146304"/>
+          </a:xfrm>
+          <a:prstGeom prst="rect">
+            <a:avLst/>
+          </a:prstGeom>
+          <a:noFill/>
+          <a:ln/>
+        </p:spPr>
+        <p:txBody>
+          <a:bodyPr wrap="square" lIns="0" tIns="0" rIns="0" bIns="0" rtlCol="0" anchor="t"/>
+          <a:lstStyle/>
+          <a:p>
+            <a:pPr algn="ctr" indent="0" marL="0">
+              <a:buNone/>
+            </a:pPr>
+            <a:r>
+              <a:rPr lang="en-US" sz="550" b="1" dirty="0">
+                <a:solidFill>
+                  <a:srgbClr val="9A6B14"/>
+                </a:solidFill>
+                <a:latin typeface="Calibri" pitchFamily="34" charset="0"/>
+                <a:ea typeface="Calibri" pitchFamily="34" charset="-122"/>
+                <a:cs typeface="Calibri" pitchFamily="34" charset="-120"/>
+              </a:rPr>
+              <a:t>$26.5M</a:t>
+            </a:r>
+            <a:endParaRPr lang="en-US" sz="550" dirty="0"/>
+          </a:p>
+        </p:txBody>
+      </p:sp>
+      <p:sp>
+        <p:nvSpPr>
+          <p:cNvPr id="53" name="Text 51"/>
+          <p:cNvSpPr/>
+          <p:nvPr/>
+        </p:nvSpPr>
+        <p:spPr>
+          <a:xfrm>
+            <a:off x="2040255" y="4818888"/>
+            <a:ext cx="360045" cy="164592"/>
+          </a:xfrm>
+          <a:prstGeom prst="rect">
+            <a:avLst/>
+          </a:prstGeom>
+          <a:noFill/>
+          <a:ln/>
+        </p:spPr>
+        <p:txBody>
+          <a:bodyPr wrap="square" lIns="0" tIns="0" rIns="0" bIns="0" rtlCol="0" anchor="t"/>
+          <a:lstStyle/>
+          <a:p>
+            <a:pPr algn="ctr" indent="0" marL="0">
+              <a:buNone/>
+            </a:pPr>
+            <a:r>
+              <a:rPr lang="en-US" sz="700" b="1" dirty="0">
+                <a:solidFill>
+                  <a:srgbClr val="23272E"/>
+                </a:solidFill>
+                <a:latin typeface="Calibri" pitchFamily="34" charset="0"/>
+                <a:ea typeface="Calibri" pitchFamily="34" charset="-122"/>
+                <a:cs typeface="Calibri" pitchFamily="34" charset="-120"/>
+              </a:rPr>
+              <a:t>2022</a:t>
+            </a:r>
+            <a:endParaRPr lang="en-US" sz="700" dirty="0"/>
+          </a:p>
+        </p:txBody>
+      </p:sp>
+      <p:sp>
+        <p:nvSpPr>
+          <p:cNvPr id="54" name="Text 52"/>
+          <p:cNvSpPr/>
+          <p:nvPr/>
+        </p:nvSpPr>
+        <p:spPr>
+          <a:xfrm>
+            <a:off x="2003679" y="4974336"/>
+            <a:ext cx="433197" cy="146304"/>
+          </a:xfrm>
+          <a:prstGeom prst="rect">
+            <a:avLst/>
+          </a:prstGeom>
+          <a:noFill/>
+          <a:ln/>
+        </p:spPr>
+        <p:txBody>
+          <a:bodyPr wrap="square" lIns="0" tIns="0" rIns="0" bIns="0" rtlCol="0" anchor="t"/>
+          <a:lstStyle/>
+          <a:p>
+            <a:pPr algn="ctr" indent="0" marL="0">
+              <a:buNone/>
+            </a:pPr>
+            <a:r>
+              <a:rPr lang="en-US" sz="550" b="1" dirty="0">
+                <a:solidFill>
+                  <a:srgbClr val="9A6B14"/>
+                </a:solidFill>
+                <a:latin typeface="Calibri" pitchFamily="34" charset="0"/>
+                <a:ea typeface="Calibri" pitchFamily="34" charset="-122"/>
+                <a:cs typeface="Calibri" pitchFamily="34" charset="-120"/>
+              </a:rPr>
+              <a:t>$30.8M</a:t>
+            </a:r>
+            <a:endParaRPr lang="en-US" sz="550" dirty="0"/>
+          </a:p>
+        </p:txBody>
+      </p:sp>
+      <p:sp>
+        <p:nvSpPr>
+          <p:cNvPr id="55" name="Text 53"/>
+          <p:cNvSpPr/>
+          <p:nvPr/>
+        </p:nvSpPr>
+        <p:spPr>
+          <a:xfrm>
+            <a:off x="2400300" y="4818888"/>
+            <a:ext cx="360045" cy="164592"/>
+          </a:xfrm>
+          <a:prstGeom prst="rect">
+            <a:avLst/>
+          </a:prstGeom>
+          <a:noFill/>
+          <a:ln/>
+        </p:spPr>
+        <p:txBody>
+          <a:bodyPr wrap="square" lIns="0" tIns="0" rIns="0" bIns="0" rtlCol="0" anchor="t"/>
+          <a:lstStyle/>
+          <a:p>
+            <a:pPr algn="ctr" indent="0" marL="0">
+              <a:buNone/>
+            </a:pPr>
+            <a:r>
+              <a:rPr lang="en-US" sz="700" b="1" dirty="0">
+                <a:solidFill>
+                  <a:srgbClr val="23272E"/>
+                </a:solidFill>
+                <a:latin typeface="Calibri" pitchFamily="34" charset="0"/>
+                <a:ea typeface="Calibri" pitchFamily="34" charset="-122"/>
+                <a:cs typeface="Calibri" pitchFamily="34" charset="-120"/>
+              </a:rPr>
+              <a:t>2023</a:t>
+            </a:r>
+            <a:endParaRPr lang="en-US" sz="700" dirty="0"/>
+          </a:p>
+        </p:txBody>
+      </p:sp>
+      <p:sp>
+        <p:nvSpPr>
+          <p:cNvPr id="56" name="Text 54"/>
+          <p:cNvSpPr/>
+          <p:nvPr/>
+        </p:nvSpPr>
+        <p:spPr>
+          <a:xfrm>
+            <a:off x="2363724" y="4974336"/>
+            <a:ext cx="433197" cy="146304"/>
+          </a:xfrm>
+          <a:prstGeom prst="rect">
+            <a:avLst/>
+          </a:prstGeom>
+          <a:noFill/>
+          <a:ln/>
+        </p:spPr>
+        <p:txBody>
+          <a:bodyPr wrap="square" lIns="0" tIns="0" rIns="0" bIns="0" rtlCol="0" anchor="t"/>
+          <a:lstStyle/>
+          <a:p>
+            <a:pPr algn="ctr" indent="0" marL="0">
+              <a:buNone/>
+            </a:pPr>
+            <a:r>
+              <a:rPr lang="en-US" sz="550" b="1" dirty="0">
+                <a:solidFill>
+                  <a:srgbClr val="9A6B14"/>
+                </a:solidFill>
+                <a:latin typeface="Calibri" pitchFamily="34" charset="0"/>
+                <a:ea typeface="Calibri" pitchFamily="34" charset="-122"/>
+                <a:cs typeface="Calibri" pitchFamily="34" charset="-120"/>
+              </a:rPr>
+              <a:t>$115.0M</a:t>
+            </a:r>
+            <a:endParaRPr lang="en-US" sz="550" dirty="0"/>
+          </a:p>
+        </p:txBody>
+      </p:sp>
+      <p:sp>
+        <p:nvSpPr>
+          <p:cNvPr id="57" name="Text 55"/>
+          <p:cNvSpPr/>
+          <p:nvPr/>
+        </p:nvSpPr>
+        <p:spPr>
+          <a:xfrm>
+            <a:off x="2760345" y="4818888"/>
+            <a:ext cx="360045" cy="164592"/>
+          </a:xfrm>
+          <a:prstGeom prst="rect">
+            <a:avLst/>
+          </a:prstGeom>
+          <a:noFill/>
+          <a:ln/>
+        </p:spPr>
+        <p:txBody>
+          <a:bodyPr wrap="square" lIns="0" tIns="0" rIns="0" bIns="0" rtlCol="0" anchor="t"/>
+          <a:lstStyle/>
+          <a:p>
+            <a:pPr algn="ctr" indent="0" marL="0">
+              <a:buNone/>
+            </a:pPr>
+            <a:r>
+              <a:rPr lang="en-US" sz="700" b="1" dirty="0">
+                <a:solidFill>
+                  <a:srgbClr val="23272E"/>
+                </a:solidFill>
+                <a:latin typeface="Calibri" pitchFamily="34" charset="0"/>
+                <a:ea typeface="Calibri" pitchFamily="34" charset="-122"/>
+                <a:cs typeface="Calibri" pitchFamily="34" charset="-120"/>
+              </a:rPr>
+              <a:t>2024</a:t>
+            </a:r>
+            <a:endParaRPr lang="en-US" sz="700" dirty="0"/>
+          </a:p>
+        </p:txBody>
+      </p:sp>
+      <p:sp>
+        <p:nvSpPr>
+          <p:cNvPr id="58" name="Text 56"/>
+          <p:cNvSpPr/>
+          <p:nvPr/>
+        </p:nvSpPr>
+        <p:spPr>
+          <a:xfrm>
+            <a:off x="2723769" y="4974336"/>
+            <a:ext cx="433197" cy="146304"/>
+          </a:xfrm>
+          <a:prstGeom prst="rect">
+            <a:avLst/>
+          </a:prstGeom>
+          <a:noFill/>
+          <a:ln/>
+        </p:spPr>
+        <p:txBody>
+          <a:bodyPr wrap="square" lIns="0" tIns="0" rIns="0" bIns="0" rtlCol="0" anchor="t"/>
+          <a:lstStyle/>
+          <a:p>
+            <a:pPr algn="ctr" indent="0" marL="0">
+              <a:buNone/>
+            </a:pPr>
+            <a:r>
+              <a:rPr lang="en-US" sz="550" b="1" dirty="0">
+                <a:solidFill>
+                  <a:srgbClr val="9A6B14"/>
+                </a:solidFill>
+                <a:latin typeface="Calibri" pitchFamily="34" charset="0"/>
+                <a:ea typeface="Calibri" pitchFamily="34" charset="-122"/>
+                <a:cs typeface="Calibri" pitchFamily="34" charset="-120"/>
+              </a:rPr>
+              <a:t>$162.8M</a:t>
+            </a:r>
+            <a:endParaRPr lang="en-US" sz="550" dirty="0"/>
+          </a:p>
+        </p:txBody>
+      </p:sp>
+      <p:sp>
+        <p:nvSpPr>
+          <p:cNvPr id="59" name="Text 57"/>
+          <p:cNvSpPr/>
+          <p:nvPr/>
+        </p:nvSpPr>
+        <p:spPr>
+          <a:xfrm>
+            <a:off x="3120390" y="4818888"/>
+            <a:ext cx="360045" cy="164592"/>
+          </a:xfrm>
+          <a:prstGeom prst="rect">
+            <a:avLst/>
+          </a:prstGeom>
+          <a:noFill/>
+          <a:ln/>
+        </p:spPr>
+        <p:txBody>
+          <a:bodyPr wrap="square" lIns="0" tIns="0" rIns="0" bIns="0" rtlCol="0" anchor="t"/>
+          <a:lstStyle/>
+          <a:p>
+            <a:pPr algn="ctr" indent="0" marL="0">
+              <a:buNone/>
+            </a:pPr>
+            <a:r>
+              <a:rPr lang="en-US" sz="700" b="1" dirty="0">
+                <a:solidFill>
+                  <a:srgbClr val="23272E"/>
+                </a:solidFill>
+                <a:latin typeface="Calibri" pitchFamily="34" charset="0"/>
+                <a:ea typeface="Calibri" pitchFamily="34" charset="-122"/>
+                <a:cs typeface="Calibri" pitchFamily="34" charset="-120"/>
+              </a:rPr>
+              <a:t>2025</a:t>
+            </a:r>
+            <a:endParaRPr lang="en-US" sz="700" dirty="0"/>
+          </a:p>
+        </p:txBody>
+      </p:sp>
+      <p:sp>
+        <p:nvSpPr>
+          <p:cNvPr id="60" name="Text 58"/>
+          <p:cNvSpPr/>
+          <p:nvPr/>
+        </p:nvSpPr>
+        <p:spPr>
+          <a:xfrm>
+            <a:off x="3083814" y="4974336"/>
+            <a:ext cx="433197" cy="146304"/>
+          </a:xfrm>
+          <a:prstGeom prst="rect">
+            <a:avLst/>
+          </a:prstGeom>
+          <a:noFill/>
+          <a:ln/>
+        </p:spPr>
+        <p:txBody>
+          <a:bodyPr wrap="square" lIns="0" tIns="0" rIns="0" bIns="0" rtlCol="0" anchor="t"/>
+          <a:lstStyle/>
+          <a:p>
+            <a:pPr algn="ctr" indent="0" marL="0">
+              <a:buNone/>
+            </a:pPr>
+            <a:r>
+              <a:rPr lang="en-US" sz="550" b="1" dirty="0">
+                <a:solidFill>
+                  <a:srgbClr val="9A6B14"/>
+                </a:solidFill>
+                <a:latin typeface="Calibri" pitchFamily="34" charset="0"/>
+                <a:ea typeface="Calibri" pitchFamily="34" charset="-122"/>
+                <a:cs typeface="Calibri" pitchFamily="34" charset="-120"/>
+              </a:rPr>
+              <a:t>$130.2M</a:t>
+            </a:r>
+            <a:endParaRPr lang="en-US" sz="550" dirty="0"/>
+          </a:p>
+        </p:txBody>
+      </p:sp>
+      <p:sp>
+        <p:nvSpPr>
+          <p:cNvPr id="61" name="Text 59"/>
+          <p:cNvSpPr/>
+          <p:nvPr/>
+        </p:nvSpPr>
+        <p:spPr>
+          <a:xfrm>
+            <a:off x="3480435" y="4818888"/>
+            <a:ext cx="360045" cy="164592"/>
+          </a:xfrm>
+          <a:prstGeom prst="rect">
+            <a:avLst/>
+          </a:prstGeom>
+          <a:noFill/>
+          <a:ln/>
+        </p:spPr>
+        <p:txBody>
+          <a:bodyPr wrap="square" lIns="0" tIns="0" rIns="0" bIns="0" rtlCol="0" anchor="t"/>
+          <a:lstStyle/>
+          <a:p>
+            <a:pPr algn="ctr" indent="0" marL="0">
+              <a:buNone/>
+            </a:pPr>
+            <a:r>
+              <a:rPr lang="en-US" sz="700" b="1" dirty="0">
+                <a:solidFill>
+                  <a:srgbClr val="23272E"/>
+                </a:solidFill>
+                <a:latin typeface="Calibri" pitchFamily="34" charset="0"/>
+                <a:ea typeface="Calibri" pitchFamily="34" charset="-122"/>
+                <a:cs typeface="Calibri" pitchFamily="34" charset="-120"/>
+              </a:rPr>
+              <a:t>2026</a:t>
+            </a:r>
+            <a:endParaRPr lang="en-US" sz="700" dirty="0"/>
+          </a:p>
+        </p:txBody>
+      </p:sp>
+      <p:sp>
+        <p:nvSpPr>
+          <p:cNvPr id="62" name="Text 60"/>
+          <p:cNvSpPr/>
+          <p:nvPr/>
+        </p:nvSpPr>
+        <p:spPr>
+          <a:xfrm>
+            <a:off x="3443859" y="4974336"/>
+            <a:ext cx="433197" cy="146304"/>
+          </a:xfrm>
+          <a:prstGeom prst="rect">
+            <a:avLst/>
+          </a:prstGeom>
+          <a:noFill/>
+          <a:ln/>
+        </p:spPr>
+        <p:txBody>
+          <a:bodyPr wrap="square" lIns="0" tIns="0" rIns="0" bIns="0" rtlCol="0" anchor="t"/>
+          <a:lstStyle/>
+          <a:p>
+            <a:pPr algn="ctr" indent="0" marL="0">
+              <a:buNone/>
+            </a:pPr>
+            <a:r>
+              <a:rPr lang="en-US" sz="550" b="1" dirty="0">
+                <a:solidFill>
+                  <a:srgbClr val="9A6B14"/>
+                </a:solidFill>
+                <a:latin typeface="Calibri" pitchFamily="34" charset="0"/>
+                <a:ea typeface="Calibri" pitchFamily="34" charset="-122"/>
+                <a:cs typeface="Calibri" pitchFamily="34" charset="-120"/>
+              </a:rPr>
+              <a:t>$153.3M</a:t>
+            </a:r>
+            <a:endParaRPr lang="en-US" sz="550" dirty="0"/>
+          </a:p>
+        </p:txBody>
+      </p:sp>
+      <p:sp>
+        <p:nvSpPr>
+          <p:cNvPr id="63" name="Shape 61"/>
+          <p:cNvSpPr/>
+          <p:nvPr/>
+        </p:nvSpPr>
+        <p:spPr>
+          <a:xfrm>
+            <a:off x="1051560" y="3291840"/>
+            <a:ext cx="146304" cy="91440"/>
+          </a:xfrm>
+          <a:prstGeom prst="rect">
+            <a:avLst/>
+          </a:prstGeom>
+          <a:solidFill>
+            <a:srgbClr val="1E2761"/>
+          </a:solidFill>
+          <a:ln/>
+        </p:spPr>
+      </p:sp>
+      <p:sp>
+        <p:nvSpPr>
+          <p:cNvPr id="64" name="Text 62"/>
+          <p:cNvSpPr/>
+          <p:nvPr/>
+        </p:nvSpPr>
+        <p:spPr>
+          <a:xfrm>
+            <a:off x="1234440" y="3227832"/>
+            <a:ext cx="868680" cy="182880"/>
           </a:xfrm>
           <a:prstGeom prst="rect">
             <a:avLst/>
@@ -2211,65 +2855,6 @@
           <a:bodyPr wrap="square" lIns="0" tIns="0" rIns="0" bIns="0" rtlCol="0" anchor="ctr"/>
           <a:lstStyle/>
           <a:p>
-            <a:pPr algn="ctr" indent="0" marL="0">
-              <a:buNone/>
-            </a:pPr>
-            <a:r>
-              <a:rPr lang="en-US" sz="700" b="1" dirty="0">
-                <a:solidFill>
-                  <a:srgbClr val="9A6B14"/>
-                </a:solidFill>
-                <a:latin typeface="Calibri" pitchFamily="34" charset="0"/>
-                <a:ea typeface="Calibri" pitchFamily="34" charset="-122"/>
-                <a:cs typeface="Calibri" pitchFamily="34" charset="-120"/>
-              </a:rPr>
-              <a:t>$162.8M</a:t>
-            </a:r>
-            <a:endParaRPr lang="en-US" sz="700" dirty="0"/>
-          </a:p>
-        </p:txBody>
-      </p:sp>
-      <p:sp>
-        <p:nvSpPr>
-          <p:cNvPr id="48" name="Shape 46"/>
-          <p:cNvSpPr/>
-          <p:nvPr/>
-        </p:nvSpPr>
-        <p:spPr>
-          <a:xfrm>
-            <a:off x="1051560" y="3328416"/>
-            <a:ext cx="146304" cy="91440"/>
-          </a:xfrm>
-          <a:prstGeom prst="rect">
-            <a:avLst/>
-          </a:prstGeom>
-          <a:solidFill>
-            <a:srgbClr val="1E2761"/>
-          </a:solidFill>
-          <a:ln/>
-        </p:spPr>
-      </p:sp>
-      <p:sp>
-        <p:nvSpPr>
-          <p:cNvPr id="49" name="Text 47"/>
-          <p:cNvSpPr/>
-          <p:nvPr/>
-        </p:nvSpPr>
-        <p:spPr>
-          <a:xfrm>
-            <a:off x="1234440" y="3264408"/>
-            <a:ext cx="868680" cy="182880"/>
-          </a:xfrm>
-          <a:prstGeom prst="rect">
-            <a:avLst/>
-          </a:prstGeom>
-          <a:noFill/>
-          <a:ln/>
-        </p:spPr>
-        <p:txBody>
-          <a:bodyPr wrap="square" lIns="0" tIns="0" rIns="0" bIns="0" rtlCol="0" anchor="ctr"/>
-          <a:lstStyle/>
-          <a:p>
             <a:pPr indent="0" marL="0">
               <a:buNone/>
             </a:pPr>
@@ -2290,13 +2875,13 @@
       </p:sp>
       <p:sp>
         <p:nvSpPr>
-          <p:cNvPr id="50" name="Shape 48"/>
-          <p:cNvSpPr/>
-          <p:nvPr/>
-        </p:nvSpPr>
-        <p:spPr>
-          <a:xfrm>
-            <a:off x="2194560" y="3374136"/>
+          <p:cNvPr id="65" name="Shape 63"/>
+          <p:cNvSpPr/>
+          <p:nvPr/>
+        </p:nvSpPr>
+        <p:spPr>
+          <a:xfrm>
+            <a:off x="2194560" y="3337560"/>
             <a:ext cx="182880" cy="0"/>
           </a:xfrm>
           <a:prstGeom prst="line">
@@ -2313,13 +2898,13 @@
       </p:sp>
       <p:sp>
         <p:nvSpPr>
-          <p:cNvPr id="51" name="Shape 49"/>
-          <p:cNvSpPr/>
-          <p:nvPr/>
-        </p:nvSpPr>
-        <p:spPr>
-          <a:xfrm>
-            <a:off x="2258568" y="3337560"/>
+          <p:cNvPr id="66" name="Shape 64"/>
+          <p:cNvSpPr/>
+          <p:nvPr/>
+        </p:nvSpPr>
+        <p:spPr>
+          <a:xfrm>
+            <a:off x="2258568" y="3300984"/>
             <a:ext cx="73152" cy="73152"/>
           </a:xfrm>
           <a:prstGeom prst="ellipse">
@@ -2333,13 +2918,13 @@
       </p:sp>
       <p:sp>
         <p:nvSpPr>
-          <p:cNvPr id="52" name="Text 50"/>
-          <p:cNvSpPr/>
-          <p:nvPr/>
-        </p:nvSpPr>
-        <p:spPr>
-          <a:xfrm>
-            <a:off x="2423160" y="3264408"/>
+          <p:cNvPr id="67" name="Text 65"/>
+          <p:cNvSpPr/>
+          <p:nvPr/>
+        </p:nvSpPr>
+        <p:spPr>
+          <a:xfrm>
+            <a:off x="2423160" y="3227832"/>
             <a:ext cx="1005840" cy="182880"/>
           </a:xfrm>
           <a:prstGeom prst="rect">
@@ -2372,13 +2957,13 @@
       </p:sp>
       <p:sp>
         <p:nvSpPr>
-          <p:cNvPr id="53" name="Text 51"/>
-          <p:cNvSpPr/>
-          <p:nvPr/>
-        </p:nvSpPr>
-        <p:spPr>
-          <a:xfrm>
-            <a:off x="960120" y="5111496"/>
+          <p:cNvPr id="68" name="Text 66"/>
+          <p:cNvSpPr/>
+          <p:nvPr/>
+        </p:nvSpPr>
+        <p:spPr>
+          <a:xfrm>
+            <a:off x="960120" y="5157216"/>
             <a:ext cx="1280160" cy="146304"/>
           </a:xfrm>
           <a:prstGeom prst="rect">

</xml_diff>